<commit_message>
docs: update proposal hearing deck; add defense reviewer and presentation script
</commit_message>
<xml_diff>
--- a/docs/HRIS_Proposal_Hearing.pptx
+++ b/docs/HRIS_Proposal_Hearing.pptx
@@ -3340,7 +3340,7 @@
           <a:p>
             <a:r>
               <a:rPr lang="en-US" dirty="0"/>
-              <a:t>Device binding is the screen that makes layer 3 of the crypto engine real. Note that the foreman never sees the word key, certificate or signature anywhere in the app.</a:t>
+              <a:t>Device binding is the screen that makes layer 3 of the crypto engine real. Note that the foreman never sees the word key, certificate or signature anywhere in the app. On the acting-foreman screen: it is an early draft that still lists certified crew workers as candidates. The rule the backend actually enforces is Site Foremen only, because only a foreman has the app and a bound device. If the panel reads the screen closely and asks, say that directly and say the screen will be revised to match.</a:t>
             </a:r>
             <a:endParaRPr lang="en-US" dirty="0"/>
           </a:p>
@@ -35269,7 +35269,7 @@
                 <a:ea typeface="Calibri" pitchFamily="34" charset="-122"/>
                 <a:cs typeface="Calibri" pitchFamily="34" charset="-120"/>
               </a:rPr>
-              <a:t>Acting foreman re-assignment lists only eligible workers: on this crew, on site, and holding a foreman certification.</a:t>
+              <a:t>An absent foreman is covered by another Site Foreman, whom the Site Engineer assigns from the web portal.</a:t>
             </a:r>
             <a:endParaRPr lang="en-US" sz="1150" dirty="0"/>
           </a:p>
@@ -35293,7 +35293,7 @@
                 <a:ea typeface="Calibri" pitchFamily="34" charset="-122"/>
                 <a:cs typeface="Calibri" pitchFamily="34" charset="-120"/>
               </a:rPr>
-              <a:t>The chosen acting foreman is notified immediately, and HR is logged.</a:t>
+              <a:t>The acting foreman is notified immediately, and the re-assignment is written to the audit log.</a:t>
             </a:r>
             <a:endParaRPr lang="en-US" sz="1150" dirty="0"/>
           </a:p>
@@ -35357,7 +35357,7 @@
                 <a:ea typeface="Calibri" pitchFamily="34" charset="-122"/>
                 <a:cs typeface="Calibri" pitchFamily="34" charset="-120"/>
               </a:rPr>
-              <a:t>Ineligible workers are shown greyed with the reason, so the foreman sees why, not just what.</a:t>
+              <a:t>A regular worker cannot act as foreman, even with a certification: they have no login and no bound device to sign with.</a:t>
             </a:r>
             <a:endParaRPr lang="en-US" sz="1100" dirty="0"/>
           </a:p>
@@ -35630,7 +35630,7 @@
                 <a:ea typeface="Calibri" pitchFamily="34" charset="-122"/>
                 <a:cs typeface="Calibri" pitchFamily="34" charset="-120"/>
               </a:rPr>
-              <a:t>Acting Foreman</a:t>
+              <a:t>Acting Foreman (draft)</a:t>
             </a:r>
             <a:endParaRPr lang="en-US" sz="1000" dirty="0"/>
           </a:p>

</xml_diff>